<commit_message>
feat: grouped apartment cards, sticky admin sidebar, UI fixes
- Group similar apartments into single cards on /kvartiralar page
- Add GroupedApartmentCard and GroupedApartmentModal components
- Floor picker shows only available floors, contact form always visible
- Fix admin sidebar to be fixed/sticky on desktop
- Add translation keys for uz/en/ru
</commit_message>
<xml_diff>
--- a/docs/Uy-Joy_Presentation.pptx
+++ b/docs/Uy-Joy_Presentation.pptx
@@ -5,17 +5,18 @@
     <p:sldMasterId id="2147483648" r:id="rId1"/>
   </p:sldMasterIdLst>
   <p:sldIdLst>
-    <p:sldId id="256" r:id="rId7"/>
-    <p:sldId id="257" r:id="rId8"/>
-    <p:sldId id="258" r:id="rId9"/>
-    <p:sldId id="259" r:id="rId10"/>
-    <p:sldId id="260" r:id="rId11"/>
-    <p:sldId id="261" r:id="rId12"/>
-    <p:sldId id="262" r:id="rId13"/>
-    <p:sldId id="263" r:id="rId14"/>
-    <p:sldId id="264" r:id="rId15"/>
+    <p:sldId id="256" r:id="rId2"/>
+    <p:sldId id="257" r:id="rId3"/>
+    <p:sldId id="258" r:id="rId4"/>
+    <p:sldId id="259" r:id="rId5"/>
+    <p:sldId id="260" r:id="rId6"/>
+    <p:sldId id="261" r:id="rId7"/>
+    <p:sldId id="262" r:id="rId8"/>
+    <p:sldId id="263" r:id="rId9"/>
+    <p:sldId id="264" r:id="rId10"/>
+    <p:sldId id="265" r:id="rId11"/>
   </p:sldIdLst>
-  <p:sldSz cx="12191695" cy="6858000" type="screen4x3"/>
+  <p:sldSz cx="12192000" cy="6858000"/>
   <p:notesSz cx="6858000" cy="9144000"/>
   <p:defaultTextStyle>
     <a:defPPr>
@@ -112,6 +113,22 @@
       </a:defRPr>
     </a:lvl9pPr>
   </p:defaultTextStyle>
+  <p:extLst>
+    <p:ext uri="{EFAFB233-063F-42B5-8137-9DF3F51BA10A}">
+      <p15:sldGuideLst xmlns:p15="http://schemas.microsoft.com/office/powerpoint/2012/main">
+        <p15:guide id="1" orient="horz" pos="2160">
+          <p15:clr>
+            <a:srgbClr val="A4A3A4"/>
+          </p15:clr>
+        </p15:guide>
+        <p15:guide id="2" pos="2880">
+          <p15:clr>
+            <a:srgbClr val="A4A3A4"/>
+          </p15:clr>
+        </p15:guide>
+      </p15:sldGuideLst>
+    </p:ext>
+  </p:extLst>
 </p:presentation>
 </file>
 
@@ -153,10 +170,9 @@
           <a:lstStyle/>
           <a:p>
             <a:r>
-              <a:rPr lang="en-US" smtClean="0"/>
+              <a:rPr lang="en-US"/>
               <a:t>Click to edit Master title style</a:t>
             </a:r>
-            <a:endParaRPr lang="en-US"/>
           </a:p>
         </p:txBody>
       </p:sp>
@@ -272,10 +288,9 @@
           </a:lstStyle>
           <a:p>
             <a:r>
-              <a:rPr lang="en-US" smtClean="0"/>
+              <a:rPr lang="en-US"/>
               <a:t>Click to edit Master subtitle style</a:t>
             </a:r>
-            <a:endParaRPr lang="en-US"/>
           </a:p>
         </p:txBody>
       </p:sp>
@@ -296,7 +311,7 @@
           <a:p>
             <a:fld id="{5BCAD085-E8A6-8845-BD4E-CB4CCA059FC4}" type="datetimeFigureOut">
               <a:rPr lang="en-US" smtClean="0"/>
-              <a:t>1/27/13</a:t>
+              <a:t>3/5/26</a:t>
             </a:fld>
             <a:endParaRPr lang="en-US"/>
           </a:p>
@@ -390,10 +405,9 @@
           <a:lstStyle/>
           <a:p>
             <a:r>
-              <a:rPr lang="en-US" smtClean="0"/>
+              <a:rPr lang="en-US"/>
               <a:t>Click to edit Master title style</a:t>
             </a:r>
-            <a:endParaRPr lang="en-US"/>
           </a:p>
         </p:txBody>
       </p:sp>
@@ -414,38 +428,37 @@
           <a:p>
             <a:pPr lvl="0"/>
             <a:r>
-              <a:rPr lang="en-US" smtClean="0"/>
+              <a:rPr lang="en-US"/>
               <a:t>Click to edit Master text styles</a:t>
             </a:r>
           </a:p>
           <a:p>
             <a:pPr lvl="1"/>
             <a:r>
-              <a:rPr lang="en-US" smtClean="0"/>
+              <a:rPr lang="en-US"/>
               <a:t>Second level</a:t>
             </a:r>
           </a:p>
           <a:p>
             <a:pPr lvl="2"/>
             <a:r>
-              <a:rPr lang="en-US" smtClean="0"/>
+              <a:rPr lang="en-US"/>
               <a:t>Third level</a:t>
             </a:r>
           </a:p>
           <a:p>
             <a:pPr lvl="3"/>
             <a:r>
-              <a:rPr lang="en-US" smtClean="0"/>
+              <a:rPr lang="en-US"/>
               <a:t>Fourth level</a:t>
             </a:r>
           </a:p>
           <a:p>
             <a:pPr lvl="4"/>
             <a:r>
-              <a:rPr lang="en-US" smtClean="0"/>
+              <a:rPr lang="en-US"/>
               <a:t>Fifth level</a:t>
             </a:r>
-            <a:endParaRPr lang="en-US"/>
           </a:p>
         </p:txBody>
       </p:sp>
@@ -466,7 +479,7 @@
           <a:p>
             <a:fld id="{5BCAD085-E8A6-8845-BD4E-CB4CCA059FC4}" type="datetimeFigureOut">
               <a:rPr lang="en-US" smtClean="0"/>
-              <a:t>1/27/13</a:t>
+              <a:t>3/5/26</a:t>
             </a:fld>
             <a:endParaRPr lang="en-US"/>
           </a:p>
@@ -565,10 +578,9 @@
           <a:lstStyle/>
           <a:p>
             <a:r>
-              <a:rPr lang="en-US" smtClean="0"/>
+              <a:rPr lang="en-US"/>
               <a:t>Click to edit Master title style</a:t>
             </a:r>
-            <a:endParaRPr lang="en-US"/>
           </a:p>
         </p:txBody>
       </p:sp>
@@ -594,38 +606,37 @@
           <a:p>
             <a:pPr lvl="0"/>
             <a:r>
-              <a:rPr lang="en-US" smtClean="0"/>
+              <a:rPr lang="en-US"/>
               <a:t>Click to edit Master text styles</a:t>
             </a:r>
           </a:p>
           <a:p>
             <a:pPr lvl="1"/>
             <a:r>
-              <a:rPr lang="en-US" smtClean="0"/>
+              <a:rPr lang="en-US"/>
               <a:t>Second level</a:t>
             </a:r>
           </a:p>
           <a:p>
             <a:pPr lvl="2"/>
             <a:r>
-              <a:rPr lang="en-US" smtClean="0"/>
+              <a:rPr lang="en-US"/>
               <a:t>Third level</a:t>
             </a:r>
           </a:p>
           <a:p>
             <a:pPr lvl="3"/>
             <a:r>
-              <a:rPr lang="en-US" smtClean="0"/>
+              <a:rPr lang="en-US"/>
               <a:t>Fourth level</a:t>
             </a:r>
           </a:p>
           <a:p>
             <a:pPr lvl="4"/>
             <a:r>
-              <a:rPr lang="en-US" smtClean="0"/>
+              <a:rPr lang="en-US"/>
               <a:t>Fifth level</a:t>
             </a:r>
-            <a:endParaRPr lang="en-US"/>
           </a:p>
         </p:txBody>
       </p:sp>
@@ -646,7 +657,7 @@
           <a:p>
             <a:fld id="{5BCAD085-E8A6-8845-BD4E-CB4CCA059FC4}" type="datetimeFigureOut">
               <a:rPr lang="en-US" smtClean="0"/>
-              <a:t>1/27/13</a:t>
+              <a:t>3/5/26</a:t>
             </a:fld>
             <a:endParaRPr lang="en-US"/>
           </a:p>
@@ -740,10 +751,9 @@
           <a:lstStyle/>
           <a:p>
             <a:r>
-              <a:rPr lang="en-US" smtClean="0"/>
+              <a:rPr lang="en-US"/>
               <a:t>Click to edit Master title style</a:t>
             </a:r>
-            <a:endParaRPr lang="en-US"/>
           </a:p>
         </p:txBody>
       </p:sp>
@@ -764,38 +774,37 @@
           <a:p>
             <a:pPr lvl="0"/>
             <a:r>
-              <a:rPr lang="en-US" smtClean="0"/>
+              <a:rPr lang="en-US"/>
               <a:t>Click to edit Master text styles</a:t>
             </a:r>
           </a:p>
           <a:p>
             <a:pPr lvl="1"/>
             <a:r>
-              <a:rPr lang="en-US" smtClean="0"/>
+              <a:rPr lang="en-US"/>
               <a:t>Second level</a:t>
             </a:r>
           </a:p>
           <a:p>
             <a:pPr lvl="2"/>
             <a:r>
-              <a:rPr lang="en-US" smtClean="0"/>
+              <a:rPr lang="en-US"/>
               <a:t>Third level</a:t>
             </a:r>
           </a:p>
           <a:p>
             <a:pPr lvl="3"/>
             <a:r>
-              <a:rPr lang="en-US" smtClean="0"/>
+              <a:rPr lang="en-US"/>
               <a:t>Fourth level</a:t>
             </a:r>
           </a:p>
           <a:p>
             <a:pPr lvl="4"/>
             <a:r>
-              <a:rPr lang="en-US" smtClean="0"/>
+              <a:rPr lang="en-US"/>
               <a:t>Fifth level</a:t>
             </a:r>
-            <a:endParaRPr lang="en-US"/>
           </a:p>
         </p:txBody>
       </p:sp>
@@ -816,7 +825,7 @@
           <a:p>
             <a:fld id="{5BCAD085-E8A6-8845-BD4E-CB4CCA059FC4}" type="datetimeFigureOut">
               <a:rPr lang="en-US" smtClean="0"/>
-              <a:t>1/27/13</a:t>
+              <a:t>3/5/26</a:t>
             </a:fld>
             <a:endParaRPr lang="en-US"/>
           </a:p>
@@ -919,10 +928,9 @@
           </a:lstStyle>
           <a:p>
             <a:r>
-              <a:rPr lang="en-US" smtClean="0"/>
+              <a:rPr lang="en-US"/>
               <a:t>Click to edit Master title style</a:t>
             </a:r>
-            <a:endParaRPr lang="en-US"/>
           </a:p>
         </p:txBody>
       </p:sp>
@@ -1039,7 +1047,7 @@
           <a:p>
             <a:pPr lvl="0"/>
             <a:r>
-              <a:rPr lang="en-US" smtClean="0"/>
+              <a:rPr lang="en-US"/>
               <a:t>Click to edit Master text styles</a:t>
             </a:r>
           </a:p>
@@ -1062,7 +1070,7 @@
           <a:p>
             <a:fld id="{5BCAD085-E8A6-8845-BD4E-CB4CCA059FC4}" type="datetimeFigureOut">
               <a:rPr lang="en-US" smtClean="0"/>
-              <a:t>1/27/13</a:t>
+              <a:t>3/5/26</a:t>
             </a:fld>
             <a:endParaRPr lang="en-US"/>
           </a:p>
@@ -1156,10 +1164,9 @@
           <a:lstStyle/>
           <a:p>
             <a:r>
-              <a:rPr lang="en-US" smtClean="0"/>
+              <a:rPr lang="en-US"/>
               <a:t>Click to edit Master title style</a:t>
             </a:r>
-            <a:endParaRPr lang="en-US"/>
           </a:p>
         </p:txBody>
       </p:sp>
@@ -1213,38 +1220,37 @@
           <a:p>
             <a:pPr lvl="0"/>
             <a:r>
-              <a:rPr lang="en-US" smtClean="0"/>
+              <a:rPr lang="en-US"/>
               <a:t>Click to edit Master text styles</a:t>
             </a:r>
           </a:p>
           <a:p>
             <a:pPr lvl="1"/>
             <a:r>
-              <a:rPr lang="en-US" smtClean="0"/>
+              <a:rPr lang="en-US"/>
               <a:t>Second level</a:t>
             </a:r>
           </a:p>
           <a:p>
             <a:pPr lvl="2"/>
             <a:r>
-              <a:rPr lang="en-US" smtClean="0"/>
+              <a:rPr lang="en-US"/>
               <a:t>Third level</a:t>
             </a:r>
           </a:p>
           <a:p>
             <a:pPr lvl="3"/>
             <a:r>
-              <a:rPr lang="en-US" smtClean="0"/>
+              <a:rPr lang="en-US"/>
               <a:t>Fourth level</a:t>
             </a:r>
           </a:p>
           <a:p>
             <a:pPr lvl="4"/>
             <a:r>
-              <a:rPr lang="en-US" smtClean="0"/>
+              <a:rPr lang="en-US"/>
               <a:t>Fifth level</a:t>
             </a:r>
-            <a:endParaRPr lang="en-US"/>
           </a:p>
         </p:txBody>
       </p:sp>
@@ -1298,38 +1304,37 @@
           <a:p>
             <a:pPr lvl="0"/>
             <a:r>
-              <a:rPr lang="en-US" smtClean="0"/>
+              <a:rPr lang="en-US"/>
               <a:t>Click to edit Master text styles</a:t>
             </a:r>
           </a:p>
           <a:p>
             <a:pPr lvl="1"/>
             <a:r>
-              <a:rPr lang="en-US" smtClean="0"/>
+              <a:rPr lang="en-US"/>
               <a:t>Second level</a:t>
             </a:r>
           </a:p>
           <a:p>
             <a:pPr lvl="2"/>
             <a:r>
-              <a:rPr lang="en-US" smtClean="0"/>
+              <a:rPr lang="en-US"/>
               <a:t>Third level</a:t>
             </a:r>
           </a:p>
           <a:p>
             <a:pPr lvl="3"/>
             <a:r>
-              <a:rPr lang="en-US" smtClean="0"/>
+              <a:rPr lang="en-US"/>
               <a:t>Fourth level</a:t>
             </a:r>
           </a:p>
           <a:p>
             <a:pPr lvl="4"/>
             <a:r>
-              <a:rPr lang="en-US" smtClean="0"/>
+              <a:rPr lang="en-US"/>
               <a:t>Fifth level</a:t>
             </a:r>
-            <a:endParaRPr lang="en-US"/>
           </a:p>
         </p:txBody>
       </p:sp>
@@ -1350,7 +1355,7 @@
           <a:p>
             <a:fld id="{5BCAD085-E8A6-8845-BD4E-CB4CCA059FC4}" type="datetimeFigureOut">
               <a:rPr lang="en-US" smtClean="0"/>
-              <a:t>1/27/13</a:t>
+              <a:t>3/5/26</a:t>
             </a:fld>
             <a:endParaRPr lang="en-US"/>
           </a:p>
@@ -1448,10 +1453,9 @@
           </a:lstStyle>
           <a:p>
             <a:r>
-              <a:rPr lang="en-US" smtClean="0"/>
+              <a:rPr lang="en-US"/>
               <a:t>Click to edit Master title style</a:t>
             </a:r>
-            <a:endParaRPr lang="en-US"/>
           </a:p>
         </p:txBody>
       </p:sp>
@@ -1514,7 +1518,7 @@
           <a:p>
             <a:pPr lvl="0"/>
             <a:r>
-              <a:rPr lang="en-US" smtClean="0"/>
+              <a:rPr lang="en-US"/>
               <a:t>Click to edit Master text styles</a:t>
             </a:r>
           </a:p>
@@ -1570,38 +1574,37 @@
           <a:p>
             <a:pPr lvl="0"/>
             <a:r>
-              <a:rPr lang="en-US" smtClean="0"/>
+              <a:rPr lang="en-US"/>
               <a:t>Click to edit Master text styles</a:t>
             </a:r>
           </a:p>
           <a:p>
             <a:pPr lvl="1"/>
             <a:r>
-              <a:rPr lang="en-US" smtClean="0"/>
+              <a:rPr lang="en-US"/>
               <a:t>Second level</a:t>
             </a:r>
           </a:p>
           <a:p>
             <a:pPr lvl="2"/>
             <a:r>
-              <a:rPr lang="en-US" smtClean="0"/>
+              <a:rPr lang="en-US"/>
               <a:t>Third level</a:t>
             </a:r>
           </a:p>
           <a:p>
             <a:pPr lvl="3"/>
             <a:r>
-              <a:rPr lang="en-US" smtClean="0"/>
+              <a:rPr lang="en-US"/>
               <a:t>Fourth level</a:t>
             </a:r>
           </a:p>
           <a:p>
             <a:pPr lvl="4"/>
             <a:r>
-              <a:rPr lang="en-US" smtClean="0"/>
+              <a:rPr lang="en-US"/>
               <a:t>Fifth level</a:t>
             </a:r>
-            <a:endParaRPr lang="en-US"/>
           </a:p>
         </p:txBody>
       </p:sp>
@@ -1664,7 +1667,7 @@
           <a:p>
             <a:pPr lvl="0"/>
             <a:r>
-              <a:rPr lang="en-US" smtClean="0"/>
+              <a:rPr lang="en-US"/>
               <a:t>Click to edit Master text styles</a:t>
             </a:r>
           </a:p>
@@ -1720,38 +1723,37 @@
           <a:p>
             <a:pPr lvl="0"/>
             <a:r>
-              <a:rPr lang="en-US" smtClean="0"/>
+              <a:rPr lang="en-US"/>
               <a:t>Click to edit Master text styles</a:t>
             </a:r>
           </a:p>
           <a:p>
             <a:pPr lvl="1"/>
             <a:r>
-              <a:rPr lang="en-US" smtClean="0"/>
+              <a:rPr lang="en-US"/>
               <a:t>Second level</a:t>
             </a:r>
           </a:p>
           <a:p>
             <a:pPr lvl="2"/>
             <a:r>
-              <a:rPr lang="en-US" smtClean="0"/>
+              <a:rPr lang="en-US"/>
               <a:t>Third level</a:t>
             </a:r>
           </a:p>
           <a:p>
             <a:pPr lvl="3"/>
             <a:r>
-              <a:rPr lang="en-US" smtClean="0"/>
+              <a:rPr lang="en-US"/>
               <a:t>Fourth level</a:t>
             </a:r>
           </a:p>
           <a:p>
             <a:pPr lvl="4"/>
             <a:r>
-              <a:rPr lang="en-US" smtClean="0"/>
+              <a:rPr lang="en-US"/>
               <a:t>Fifth level</a:t>
             </a:r>
-            <a:endParaRPr lang="en-US"/>
           </a:p>
         </p:txBody>
       </p:sp>
@@ -1772,7 +1774,7 @@
           <a:p>
             <a:fld id="{5BCAD085-E8A6-8845-BD4E-CB4CCA059FC4}" type="datetimeFigureOut">
               <a:rPr lang="en-US" smtClean="0"/>
-              <a:t>1/27/13</a:t>
+              <a:t>3/5/26</a:t>
             </a:fld>
             <a:endParaRPr lang="en-US"/>
           </a:p>
@@ -1866,10 +1868,9 @@
           <a:lstStyle/>
           <a:p>
             <a:r>
-              <a:rPr lang="en-US" smtClean="0"/>
+              <a:rPr lang="en-US"/>
               <a:t>Click to edit Master title style</a:t>
             </a:r>
-            <a:endParaRPr lang="en-US"/>
           </a:p>
         </p:txBody>
       </p:sp>
@@ -1890,7 +1891,7 @@
           <a:p>
             <a:fld id="{5BCAD085-E8A6-8845-BD4E-CB4CCA059FC4}" type="datetimeFigureOut">
               <a:rPr lang="en-US" smtClean="0"/>
-              <a:t>1/27/13</a:t>
+              <a:t>3/5/26</a:t>
             </a:fld>
             <a:endParaRPr lang="en-US"/>
           </a:p>
@@ -1985,7 +1986,7 @@
           <a:p>
             <a:fld id="{5BCAD085-E8A6-8845-BD4E-CB4CCA059FC4}" type="datetimeFigureOut">
               <a:rPr lang="en-US" smtClean="0"/>
-              <a:t>1/27/13</a:t>
+              <a:t>3/5/26</a:t>
             </a:fld>
             <a:endParaRPr lang="en-US"/>
           </a:p>
@@ -2088,10 +2089,9 @@
           </a:lstStyle>
           <a:p>
             <a:r>
-              <a:rPr lang="en-US" smtClean="0"/>
+              <a:rPr lang="en-US"/>
               <a:t>Click to edit Master title style</a:t>
             </a:r>
-            <a:endParaRPr lang="en-US"/>
           </a:p>
         </p:txBody>
       </p:sp>
@@ -2145,38 +2145,37 @@
           <a:p>
             <a:pPr lvl="0"/>
             <a:r>
-              <a:rPr lang="en-US" smtClean="0"/>
+              <a:rPr lang="en-US"/>
               <a:t>Click to edit Master text styles</a:t>
             </a:r>
           </a:p>
           <a:p>
             <a:pPr lvl="1"/>
             <a:r>
-              <a:rPr lang="en-US" smtClean="0"/>
+              <a:rPr lang="en-US"/>
               <a:t>Second level</a:t>
             </a:r>
           </a:p>
           <a:p>
             <a:pPr lvl="2"/>
             <a:r>
-              <a:rPr lang="en-US" smtClean="0"/>
+              <a:rPr lang="en-US"/>
               <a:t>Third level</a:t>
             </a:r>
           </a:p>
           <a:p>
             <a:pPr lvl="3"/>
             <a:r>
-              <a:rPr lang="en-US" smtClean="0"/>
+              <a:rPr lang="en-US"/>
               <a:t>Fourth level</a:t>
             </a:r>
           </a:p>
           <a:p>
             <a:pPr lvl="4"/>
             <a:r>
-              <a:rPr lang="en-US" smtClean="0"/>
+              <a:rPr lang="en-US"/>
               <a:t>Fifth level</a:t>
             </a:r>
-            <a:endParaRPr lang="en-US"/>
           </a:p>
         </p:txBody>
       </p:sp>
@@ -2239,7 +2238,7 @@
           <a:p>
             <a:pPr lvl="0"/>
             <a:r>
-              <a:rPr lang="en-US" smtClean="0"/>
+              <a:rPr lang="en-US"/>
               <a:t>Click to edit Master text styles</a:t>
             </a:r>
           </a:p>
@@ -2262,7 +2261,7 @@
           <a:p>
             <a:fld id="{5BCAD085-E8A6-8845-BD4E-CB4CCA059FC4}" type="datetimeFigureOut">
               <a:rPr lang="en-US" smtClean="0"/>
-              <a:t>1/27/13</a:t>
+              <a:t>3/5/26</a:t>
             </a:fld>
             <a:endParaRPr lang="en-US"/>
           </a:p>
@@ -2365,10 +2364,9 @@
           </a:lstStyle>
           <a:p>
             <a:r>
-              <a:rPr lang="en-US" smtClean="0"/>
+              <a:rPr lang="en-US"/>
               <a:t>Click to edit Master title style</a:t>
             </a:r>
-            <a:endParaRPr lang="en-US"/>
           </a:p>
         </p:txBody>
       </p:sp>
@@ -2492,7 +2490,7 @@
           <a:p>
             <a:pPr lvl="0"/>
             <a:r>
-              <a:rPr lang="en-US" smtClean="0"/>
+              <a:rPr lang="en-US"/>
               <a:t>Click to edit Master text styles</a:t>
             </a:r>
           </a:p>
@@ -2515,7 +2513,7 @@
           <a:p>
             <a:fld id="{5BCAD085-E8A6-8845-BD4E-CB4CCA059FC4}" type="datetimeFigureOut">
               <a:rPr lang="en-US" smtClean="0"/>
-              <a:t>1/27/13</a:t>
+              <a:t>3/5/26</a:t>
             </a:fld>
             <a:endParaRPr lang="en-US"/>
           </a:p>
@@ -2624,10 +2622,9 @@
           <a:lstStyle/>
           <a:p>
             <a:r>
-              <a:rPr lang="en-US" smtClean="0"/>
+              <a:rPr lang="en-US"/>
               <a:t>Click to edit Master title style</a:t>
             </a:r>
-            <a:endParaRPr lang="en-US"/>
           </a:p>
         </p:txBody>
       </p:sp>
@@ -2658,38 +2655,37 @@
           <a:p>
             <a:pPr lvl="0"/>
             <a:r>
-              <a:rPr lang="en-US" smtClean="0"/>
+              <a:rPr lang="en-US"/>
               <a:t>Click to edit Master text styles</a:t>
             </a:r>
           </a:p>
           <a:p>
             <a:pPr lvl="1"/>
             <a:r>
-              <a:rPr lang="en-US" smtClean="0"/>
+              <a:rPr lang="en-US"/>
               <a:t>Second level</a:t>
             </a:r>
           </a:p>
           <a:p>
             <a:pPr lvl="2"/>
             <a:r>
-              <a:rPr lang="en-US" smtClean="0"/>
+              <a:rPr lang="en-US"/>
               <a:t>Third level</a:t>
             </a:r>
           </a:p>
           <a:p>
             <a:pPr lvl="3"/>
             <a:r>
-              <a:rPr lang="en-US" smtClean="0"/>
+              <a:rPr lang="en-US"/>
               <a:t>Fourth level</a:t>
             </a:r>
           </a:p>
           <a:p>
             <a:pPr lvl="4"/>
             <a:r>
-              <a:rPr lang="en-US" smtClean="0"/>
+              <a:rPr lang="en-US"/>
               <a:t>Fifth level</a:t>
             </a:r>
-            <a:endParaRPr lang="en-US"/>
           </a:p>
         </p:txBody>
       </p:sp>
@@ -2728,7 +2724,7 @@
           <a:p>
             <a:fld id="{5BCAD085-E8A6-8845-BD4E-CB4CCA059FC4}" type="datetimeFigureOut">
               <a:rPr lang="en-US" smtClean="0"/>
-              <a:t>1/27/13</a:t>
+              <a:t>3/5/26</a:t>
             </a:fld>
             <a:endParaRPr lang="en-US"/>
           </a:p>
@@ -3087,7 +3083,7 @@
 </file>
 
 <file path=ppt/slides/slide1.xml><?xml version="1.0" encoding="utf-8"?>
-<p:sld xmlns:a="http://schemas.openxmlformats.org/drawingml/2006/main" xmlns:p="http://schemas.openxmlformats.org/presentationml/2006/main" xmlns:r="http://schemas.openxmlformats.org/officeDocument/2006/relationships">
+<p:sld xmlns:a="http://schemas.openxmlformats.org/drawingml/2006/main" xmlns:r="http://schemas.openxmlformats.org/officeDocument/2006/relationships" xmlns:p="http://schemas.openxmlformats.org/presentationml/2006/main">
   <p:cSld>
     <p:spTree>
       <p:nvGrpSpPr>
@@ -3095,7 +3091,14 @@
         <p:cNvGrpSpPr/>
         <p:nvPr/>
       </p:nvGrpSpPr>
-      <p:grpSpPr/>
+      <p:grpSpPr>
+        <a:xfrm>
+          <a:off x="0" y="0"/>
+          <a:ext cx="0" cy="0"/>
+          <a:chOff x="0" y="0"/>
+          <a:chExt cx="0" cy="0"/>
+        </a:xfrm>
+      </p:grpSpPr>
       <p:sp>
         <p:nvSpPr>
           <p:cNvPr id="2" name="Rectangle 1"/>
@@ -3136,6 +3139,7 @@
           <a:lstStyle/>
           <a:p>
             <a:pPr algn="ctr"/>
+            <a:endParaRPr/>
           </a:p>
         </p:txBody>
       </p:sp>
@@ -3194,8 +3198,161 @@
 </p:sld>
 </file>
 
+<file path=ppt/slides/slide10.xml><?xml version="1.0" encoding="utf-8"?>
+<p:sld xmlns:a="http://schemas.openxmlformats.org/drawingml/2006/main" xmlns:r="http://schemas.openxmlformats.org/officeDocument/2006/relationships" xmlns:p="http://schemas.openxmlformats.org/presentationml/2006/main">
+  <p:cSld>
+    <p:spTree>
+      <p:nvGrpSpPr>
+        <p:cNvPr id="1" name="">
+          <a:extLst>
+            <a:ext uri="{FF2B5EF4-FFF2-40B4-BE49-F238E27FC236}">
+              <a16:creationId xmlns:a16="http://schemas.microsoft.com/office/drawing/2014/main" id="{10BF4A03-785E-2A4C-6576-FB468E2E382D}"/>
+            </a:ext>
+          </a:extLst>
+        </p:cNvPr>
+        <p:cNvGrpSpPr/>
+        <p:nvPr/>
+      </p:nvGrpSpPr>
+      <p:grpSpPr>
+        <a:xfrm>
+          <a:off x="0" y="0"/>
+          <a:ext cx="0" cy="0"/>
+          <a:chOff x="0" y="0"/>
+          <a:chExt cx="0" cy="0"/>
+        </a:xfrm>
+      </p:grpSpPr>
+      <p:sp>
+        <p:nvSpPr>
+          <p:cNvPr id="2" name="Rectangle 1">
+            <a:extLst>
+              <a:ext uri="{FF2B5EF4-FFF2-40B4-BE49-F238E27FC236}">
+                <a16:creationId xmlns:a16="http://schemas.microsoft.com/office/drawing/2014/main" id="{D2B8077F-7B90-5701-EF9A-DADAC3C516AE}"/>
+              </a:ext>
+            </a:extLst>
+          </p:cNvPr>
+          <p:cNvSpPr/>
+          <p:nvPr/>
+        </p:nvSpPr>
+        <p:spPr>
+          <a:xfrm>
+            <a:off x="0" y="312234"/>
+            <a:ext cx="12191695" cy="6858000"/>
+          </a:xfrm>
+          <a:prstGeom prst="rect">
+            <a:avLst/>
+          </a:prstGeom>
+          <a:solidFill>
+            <a:srgbClr val="1E2A38"/>
+          </a:solidFill>
+          <a:ln>
+            <a:noFill/>
+          </a:ln>
+        </p:spPr>
+        <p:style>
+          <a:lnRef idx="1">
+            <a:schemeClr val="accent1"/>
+          </a:lnRef>
+          <a:fillRef idx="3">
+            <a:schemeClr val="accent1"/>
+          </a:fillRef>
+          <a:effectRef idx="2">
+            <a:schemeClr val="accent1"/>
+          </a:effectRef>
+          <a:fontRef idx="minor">
+            <a:schemeClr val="lt1"/>
+          </a:fontRef>
+        </p:style>
+        <p:txBody>
+          <a:bodyPr rtlCol="0" anchor="ctr"/>
+          <a:lstStyle/>
+          <a:p>
+            <a:pPr algn="ctr"/>
+            <a:endParaRPr/>
+          </a:p>
+        </p:txBody>
+      </p:sp>
+      <p:sp>
+        <p:nvSpPr>
+          <p:cNvPr id="3" name="TextBox 2">
+            <a:extLst>
+              <a:ext uri="{FF2B5EF4-FFF2-40B4-BE49-F238E27FC236}">
+                <a16:creationId xmlns:a16="http://schemas.microsoft.com/office/drawing/2014/main" id="{C5F0FAD2-8E79-E2CA-47A3-5514C036EC72}"/>
+              </a:ext>
+            </a:extLst>
+          </p:cNvPr>
+          <p:cNvSpPr txBox="1"/>
+          <p:nvPr/>
+        </p:nvSpPr>
+        <p:spPr>
+          <a:xfrm>
+            <a:off x="457199" y="2736502"/>
+            <a:ext cx="11277295" cy="1384995"/>
+          </a:xfrm>
+          <a:prstGeom prst="rect">
+            <a:avLst/>
+          </a:prstGeom>
+          <a:noFill/>
+        </p:spPr>
+        <p:txBody>
+          <a:bodyPr wrap="square">
+            <a:spAutoFit/>
+          </a:bodyPr>
+          <a:lstStyle/>
+          <a:p>
+            <a:pPr algn="ctr">
+              <a:defRPr sz="4800" b="1">
+                <a:solidFill>
+                  <a:srgbClr val="FFFFFF"/>
+                </a:solidFill>
+              </a:defRPr>
+            </a:pPr>
+            <a:r>
+              <a:rPr lang="en-GB" sz="6000" dirty="0" err="1"/>
+              <a:t>Narx</a:t>
+            </a:r>
+            <a:r>
+              <a:rPr lang="en-GB" sz="6000" dirty="0"/>
+              <a:t>?</a:t>
+            </a:r>
+          </a:p>
+          <a:p>
+            <a:pPr algn="ctr">
+              <a:defRPr sz="2400">
+                <a:solidFill>
+                  <a:srgbClr val="C9A86A"/>
+                </a:solidFill>
+              </a:defRPr>
+            </a:pPr>
+            <a:r>
+              <a:rPr lang="en-GB" dirty="0"/>
+              <a:t> </a:t>
+            </a:r>
+            <a:r>
+              <a:rPr lang="en-GB" dirty="0" err="1"/>
+              <a:t>Qancha</a:t>
+            </a:r>
+            <a:r>
+              <a:rPr lang="en-GB" dirty="0"/>
+              <a:t>?</a:t>
+            </a:r>
+          </a:p>
+        </p:txBody>
+      </p:sp>
+    </p:spTree>
+    <p:extLst>
+      <p:ext uri="{BB962C8B-B14F-4D97-AF65-F5344CB8AC3E}">
+        <p14:creationId xmlns:p14="http://schemas.microsoft.com/office/powerpoint/2010/main" val="2045861209"/>
+      </p:ext>
+    </p:extLst>
+  </p:cSld>
+  <p:clrMapOvr>
+    <a:masterClrMapping/>
+  </p:clrMapOvr>
+</p:sld>
+</file>
+
 <file path=ppt/slides/slide2.xml><?xml version="1.0" encoding="utf-8"?>
-<p:sld xmlns:a="http://schemas.openxmlformats.org/drawingml/2006/main" xmlns:p="http://schemas.openxmlformats.org/presentationml/2006/main" xmlns:r="http://schemas.openxmlformats.org/officeDocument/2006/relationships">
+<p:sld xmlns:a="http://schemas.openxmlformats.org/drawingml/2006/main" xmlns:r="http://schemas.openxmlformats.org/officeDocument/2006/relationships" xmlns:p="http://schemas.openxmlformats.org/presentationml/2006/main">
   <p:cSld>
     <p:spTree>
       <p:nvGrpSpPr>
@@ -3203,7 +3360,14 @@
         <p:cNvGrpSpPr/>
         <p:nvPr/>
       </p:nvGrpSpPr>
-      <p:grpSpPr/>
+      <p:grpSpPr>
+        <a:xfrm>
+          <a:off x="0" y="0"/>
+          <a:ext cx="0" cy="0"/>
+          <a:chOff x="0" y="0"/>
+          <a:chExt cx="0" cy="0"/>
+        </a:xfrm>
+      </p:grpSpPr>
       <p:sp>
         <p:nvSpPr>
           <p:cNvPr id="2" name="Rectangle 1"/>
@@ -3244,6 +3408,7 @@
           <a:lstStyle/>
           <a:p>
             <a:pPr algn="ctr"/>
+            <a:endParaRPr/>
           </a:p>
         </p:txBody>
       </p:sp>
@@ -3389,7 +3554,7 @@
 </file>
 
 <file path=ppt/slides/slide3.xml><?xml version="1.0" encoding="utf-8"?>
-<p:sld xmlns:a="http://schemas.openxmlformats.org/drawingml/2006/main" xmlns:p="http://schemas.openxmlformats.org/presentationml/2006/main" xmlns:r="http://schemas.openxmlformats.org/officeDocument/2006/relationships">
+<p:sld xmlns:a="http://schemas.openxmlformats.org/drawingml/2006/main" xmlns:r="http://schemas.openxmlformats.org/officeDocument/2006/relationships" xmlns:p="http://schemas.openxmlformats.org/presentationml/2006/main">
   <p:cSld>
     <p:spTree>
       <p:nvGrpSpPr>
@@ -3397,7 +3562,14 @@
         <p:cNvGrpSpPr/>
         <p:nvPr/>
       </p:nvGrpSpPr>
-      <p:grpSpPr/>
+      <p:grpSpPr>
+        <a:xfrm>
+          <a:off x="0" y="0"/>
+          <a:ext cx="0" cy="0"/>
+          <a:chOff x="0" y="0"/>
+          <a:chExt cx="0" cy="0"/>
+        </a:xfrm>
+      </p:grpSpPr>
       <p:sp>
         <p:nvSpPr>
           <p:cNvPr id="2" name="Rectangle 1"/>
@@ -3438,6 +3610,7 @@
           <a:lstStyle/>
           <a:p>
             <a:pPr algn="ctr"/>
+            <a:endParaRPr/>
           </a:p>
         </p:txBody>
       </p:sp>
@@ -3751,7 +3924,7 @@
 </file>
 
 <file path=ppt/slides/slide4.xml><?xml version="1.0" encoding="utf-8"?>
-<p:sld xmlns:a="http://schemas.openxmlformats.org/drawingml/2006/main" xmlns:p="http://schemas.openxmlformats.org/presentationml/2006/main" xmlns:r="http://schemas.openxmlformats.org/officeDocument/2006/relationships">
+<p:sld xmlns:a="http://schemas.openxmlformats.org/drawingml/2006/main" xmlns:r="http://schemas.openxmlformats.org/officeDocument/2006/relationships" xmlns:p="http://schemas.openxmlformats.org/presentationml/2006/main">
   <p:cSld>
     <p:spTree>
       <p:nvGrpSpPr>
@@ -3759,7 +3932,14 @@
         <p:cNvGrpSpPr/>
         <p:nvPr/>
       </p:nvGrpSpPr>
-      <p:grpSpPr/>
+      <p:grpSpPr>
+        <a:xfrm>
+          <a:off x="0" y="0"/>
+          <a:ext cx="0" cy="0"/>
+          <a:chOff x="0" y="0"/>
+          <a:chExt cx="0" cy="0"/>
+        </a:xfrm>
+      </p:grpSpPr>
       <p:sp>
         <p:nvSpPr>
           <p:cNvPr id="2" name="Rectangle 1"/>
@@ -3800,6 +3980,7 @@
           <a:lstStyle/>
           <a:p>
             <a:pPr algn="ctr"/>
+            <a:endParaRPr/>
           </a:p>
         </p:txBody>
       </p:sp>
@@ -3945,7 +4126,7 @@
 </file>
 
 <file path=ppt/slides/slide5.xml><?xml version="1.0" encoding="utf-8"?>
-<p:sld xmlns:a="http://schemas.openxmlformats.org/drawingml/2006/main" xmlns:p="http://schemas.openxmlformats.org/presentationml/2006/main" xmlns:r="http://schemas.openxmlformats.org/officeDocument/2006/relationships">
+<p:sld xmlns:a="http://schemas.openxmlformats.org/drawingml/2006/main" xmlns:r="http://schemas.openxmlformats.org/officeDocument/2006/relationships" xmlns:p="http://schemas.openxmlformats.org/presentationml/2006/main">
   <p:cSld>
     <p:spTree>
       <p:nvGrpSpPr>
@@ -3953,7 +4134,14 @@
         <p:cNvGrpSpPr/>
         <p:nvPr/>
       </p:nvGrpSpPr>
-      <p:grpSpPr/>
+      <p:grpSpPr>
+        <a:xfrm>
+          <a:off x="0" y="0"/>
+          <a:ext cx="0" cy="0"/>
+          <a:chOff x="0" y="0"/>
+          <a:chExt cx="0" cy="0"/>
+        </a:xfrm>
+      </p:grpSpPr>
       <p:sp>
         <p:nvSpPr>
           <p:cNvPr id="2" name="Rectangle 1"/>
@@ -3994,6 +4182,7 @@
           <a:lstStyle/>
           <a:p>
             <a:pPr algn="ctr"/>
+            <a:endParaRPr/>
           </a:p>
         </p:txBody>
       </p:sp>
@@ -4139,7 +4328,7 @@
 </file>
 
 <file path=ppt/slides/slide6.xml><?xml version="1.0" encoding="utf-8"?>
-<p:sld xmlns:a="http://schemas.openxmlformats.org/drawingml/2006/main" xmlns:p="http://schemas.openxmlformats.org/presentationml/2006/main" xmlns:r="http://schemas.openxmlformats.org/officeDocument/2006/relationships">
+<p:sld xmlns:a="http://schemas.openxmlformats.org/drawingml/2006/main" xmlns:r="http://schemas.openxmlformats.org/officeDocument/2006/relationships" xmlns:p="http://schemas.openxmlformats.org/presentationml/2006/main">
   <p:cSld>
     <p:spTree>
       <p:nvGrpSpPr>
@@ -4147,7 +4336,14 @@
         <p:cNvGrpSpPr/>
         <p:nvPr/>
       </p:nvGrpSpPr>
-      <p:grpSpPr/>
+      <p:grpSpPr>
+        <a:xfrm>
+          <a:off x="0" y="0"/>
+          <a:ext cx="0" cy="0"/>
+          <a:chOff x="0" y="0"/>
+          <a:chExt cx="0" cy="0"/>
+        </a:xfrm>
+      </p:grpSpPr>
       <p:sp>
         <p:nvSpPr>
           <p:cNvPr id="2" name="Rectangle 1"/>
@@ -4188,6 +4384,7 @@
           <a:lstStyle/>
           <a:p>
             <a:pPr algn="ctr"/>
+            <a:endParaRPr/>
           </a:p>
         </p:txBody>
       </p:sp>
@@ -4348,7 +4545,7 @@
 </file>
 
 <file path=ppt/slides/slide7.xml><?xml version="1.0" encoding="utf-8"?>
-<p:sld xmlns:a="http://schemas.openxmlformats.org/drawingml/2006/main" xmlns:p="http://schemas.openxmlformats.org/presentationml/2006/main" xmlns:r="http://schemas.openxmlformats.org/officeDocument/2006/relationships">
+<p:sld xmlns:a="http://schemas.openxmlformats.org/drawingml/2006/main" xmlns:r="http://schemas.openxmlformats.org/officeDocument/2006/relationships" xmlns:p="http://schemas.openxmlformats.org/presentationml/2006/main">
   <p:cSld>
     <p:spTree>
       <p:nvGrpSpPr>
@@ -4356,7 +4553,14 @@
         <p:cNvGrpSpPr/>
         <p:nvPr/>
       </p:nvGrpSpPr>
-      <p:grpSpPr/>
+      <p:grpSpPr>
+        <a:xfrm>
+          <a:off x="0" y="0"/>
+          <a:ext cx="0" cy="0"/>
+          <a:chOff x="0" y="0"/>
+          <a:chExt cx="0" cy="0"/>
+        </a:xfrm>
+      </p:grpSpPr>
       <p:sp>
         <p:nvSpPr>
           <p:cNvPr id="2" name="Rectangle 1"/>
@@ -4397,6 +4601,7 @@
           <a:lstStyle/>
           <a:p>
             <a:pPr algn="ctr"/>
+            <a:endParaRPr/>
           </a:p>
         </p:txBody>
       </p:sp>
@@ -4542,7 +4747,7 @@
 </file>
 
 <file path=ppt/slides/slide8.xml><?xml version="1.0" encoding="utf-8"?>
-<p:sld xmlns:a="http://schemas.openxmlformats.org/drawingml/2006/main" xmlns:p="http://schemas.openxmlformats.org/presentationml/2006/main" xmlns:r="http://schemas.openxmlformats.org/officeDocument/2006/relationships">
+<p:sld xmlns:a="http://schemas.openxmlformats.org/drawingml/2006/main" xmlns:r="http://schemas.openxmlformats.org/officeDocument/2006/relationships" xmlns:p="http://schemas.openxmlformats.org/presentationml/2006/main">
   <p:cSld>
     <p:spTree>
       <p:nvGrpSpPr>
@@ -4550,7 +4755,14 @@
         <p:cNvGrpSpPr/>
         <p:nvPr/>
       </p:nvGrpSpPr>
-      <p:grpSpPr/>
+      <p:grpSpPr>
+        <a:xfrm>
+          <a:off x="0" y="0"/>
+          <a:ext cx="0" cy="0"/>
+          <a:chOff x="0" y="0"/>
+          <a:chExt cx="0" cy="0"/>
+        </a:xfrm>
+      </p:grpSpPr>
       <p:sp>
         <p:nvSpPr>
           <p:cNvPr id="2" name="Rectangle 1"/>
@@ -4591,6 +4803,7 @@
           <a:lstStyle/>
           <a:p>
             <a:pPr algn="ctr"/>
+            <a:endParaRPr/>
           </a:p>
         </p:txBody>
       </p:sp>
@@ -4673,7 +4886,7 @@
         <p:spPr>
           <a:xfrm>
             <a:off x="457200" y="1920240"/>
-            <a:ext cx="5486400" cy="4572000"/>
+            <a:ext cx="2986202" cy="1128514"/>
           </a:xfrm>
           <a:prstGeom prst="rect">
             <a:avLst/>
@@ -4697,7 +4910,16 @@
               </a:defRPr>
             </a:pPr>
             <a:r>
-              <a:t>• AI yordamchi (chatbot)</a:t>
+              <a:rPr dirty="0"/>
+              <a:t>• AI </a:t>
+            </a:r>
+            <a:r>
+              <a:rPr dirty="0" err="1"/>
+              <a:t>yordamchi</a:t>
+            </a:r>
+            <a:r>
+              <a:rPr dirty="0"/>
+              <a:t> (chatbot)</a:t>
             </a:r>
           </a:p>
           <a:p>
@@ -4712,8 +4934,22 @@
               </a:defRPr>
             </a:pPr>
             <a:r>
-              <a:t>• Telegram bot orqali xabarlar</a:t>
-            </a:r>
+              <a:rPr dirty="0"/>
+              <a:t>• Telegram bot </a:t>
+            </a:r>
+            <a:r>
+              <a:rPr dirty="0" err="1"/>
+              <a:t>orqali</a:t>
+            </a:r>
+            <a:r>
+              <a:rPr dirty="0"/>
+              <a:t> </a:t>
+            </a:r>
+            <a:r>
+              <a:rPr dirty="0" err="1"/>
+              <a:t>xabarlar</a:t>
+            </a:r>
+            <a:endParaRPr dirty="0"/>
           </a:p>
           <a:p>
             <a:pPr>
@@ -4727,23 +4963,22 @@
               </a:defRPr>
             </a:pPr>
             <a:r>
-              <a:t>• Kvartiralarni solishtirish</a:t>
-            </a:r>
-          </a:p>
-          <a:p>
-            <a:pPr>
-              <a:spcAft>
-                <a:spcPts val="800"/>
-              </a:spcAft>
-              <a:defRPr sz="1800">
-                <a:solidFill>
-                  <a:srgbClr val="374151"/>
-                </a:solidFill>
-              </a:defRPr>
-            </a:pPr>
-            <a:r>
-              <a:t>• Sevimlilar ro'yxati</a:t>
-            </a:r>
+              <a:rPr dirty="0"/>
+              <a:t>• </a:t>
+            </a:r>
+            <a:r>
+              <a:rPr dirty="0" err="1"/>
+              <a:t>Kvartiralarni</a:t>
+            </a:r>
+            <a:r>
+              <a:rPr dirty="0"/>
+              <a:t> </a:t>
+            </a:r>
+            <a:r>
+              <a:rPr dirty="0" err="1"/>
+              <a:t>solishtirish</a:t>
+            </a:r>
+            <a:endParaRPr dirty="0"/>
           </a:p>
         </p:txBody>
       </p:sp>
@@ -4815,8 +5050,30 @@
               </a:defRPr>
             </a:pPr>
             <a:r>
-              <a:t>• PDF formatda yuklab olish</a:t>
-            </a:r>
+              <a:rPr dirty="0"/>
+              <a:t>• PDF </a:t>
+            </a:r>
+            <a:r>
+              <a:rPr dirty="0" err="1"/>
+              <a:t>formatda</a:t>
+            </a:r>
+            <a:r>
+              <a:rPr dirty="0"/>
+              <a:t> </a:t>
+            </a:r>
+            <a:r>
+              <a:rPr dirty="0" err="1"/>
+              <a:t>yuklab</a:t>
+            </a:r>
+            <a:r>
+              <a:rPr dirty="0"/>
+              <a:t> </a:t>
+            </a:r>
+            <a:r>
+              <a:rPr dirty="0" err="1"/>
+              <a:t>olish</a:t>
+            </a:r>
+            <a:endParaRPr dirty="0"/>
           </a:p>
           <a:p>
             <a:pPr>
@@ -4830,8 +5087,22 @@
               </a:defRPr>
             </a:pPr>
             <a:r>
-              <a:t>• Sotuvlar statistikasi</a:t>
-            </a:r>
+              <a:rPr dirty="0"/>
+              <a:t>• </a:t>
+            </a:r>
+            <a:r>
+              <a:rPr dirty="0" err="1"/>
+              <a:t>Sotuvlar</a:t>
+            </a:r>
+            <a:r>
+              <a:rPr dirty="0"/>
+              <a:t> </a:t>
+            </a:r>
+            <a:r>
+              <a:rPr dirty="0" err="1"/>
+              <a:t>statistikasi</a:t>
+            </a:r>
+            <a:endParaRPr dirty="0"/>
           </a:p>
           <a:p>
             <a:pPr>
@@ -4845,7 +5116,16 @@
               </a:defRPr>
             </a:pPr>
             <a:r>
-              <a:t>• 3D ko'rinish / Virtual tur</a:t>
+              <a:rPr dirty="0"/>
+              <a:t>• 3D </a:t>
+            </a:r>
+            <a:r>
+              <a:rPr dirty="0" err="1"/>
+              <a:t>ko'rinish</a:t>
+            </a:r>
+            <a:r>
+              <a:rPr dirty="0"/>
+              <a:t> / Virtual tur</a:t>
             </a:r>
           </a:p>
           <a:p>
@@ -4860,8 +5140,22 @@
               </a:defRPr>
             </a:pPr>
             <a:r>
-              <a:t>• Telegram orqali bildirishnomalar</a:t>
-            </a:r>
+              <a:rPr dirty="0"/>
+              <a:t>• Telegram </a:t>
+            </a:r>
+            <a:r>
+              <a:rPr dirty="0" err="1"/>
+              <a:t>orqali</a:t>
+            </a:r>
+            <a:r>
+              <a:rPr dirty="0"/>
+              <a:t> </a:t>
+            </a:r>
+            <a:r>
+              <a:rPr dirty="0" err="1"/>
+              <a:t>bildirishnomalar</a:t>
+            </a:r>
+            <a:endParaRPr dirty="0"/>
           </a:p>
         </p:txBody>
       </p:sp>
@@ -4874,7 +5168,7 @@
 </file>
 
 <file path=ppt/slides/slide9.xml><?xml version="1.0" encoding="utf-8"?>
-<p:sld xmlns:a="http://schemas.openxmlformats.org/drawingml/2006/main" xmlns:p="http://schemas.openxmlformats.org/presentationml/2006/main" xmlns:r="http://schemas.openxmlformats.org/officeDocument/2006/relationships">
+<p:sld xmlns:a="http://schemas.openxmlformats.org/drawingml/2006/main" xmlns:r="http://schemas.openxmlformats.org/officeDocument/2006/relationships" xmlns:p="http://schemas.openxmlformats.org/presentationml/2006/main">
   <p:cSld>
     <p:spTree>
       <p:nvGrpSpPr>
@@ -4882,7 +5176,14 @@
         <p:cNvGrpSpPr/>
         <p:nvPr/>
       </p:nvGrpSpPr>
-      <p:grpSpPr/>
+      <p:grpSpPr>
+        <a:xfrm>
+          <a:off x="0" y="0"/>
+          <a:ext cx="0" cy="0"/>
+          <a:chOff x="0" y="0"/>
+          <a:chExt cx="0" cy="0"/>
+        </a:xfrm>
+      </p:grpSpPr>
       <p:sp>
         <p:nvSpPr>
           <p:cNvPr id="2" name="Rectangle 1"/>
@@ -4923,6 +5224,7 @@
           <a:lstStyle/>
           <a:p>
             <a:pPr algn="ctr"/>
+            <a:endParaRPr/>
           </a:p>
         </p:txBody>
       </p:sp>

</xml_diff>